<commit_message>
docs(presentation): apply checkpoint review fixes and refresh current UI screenshots
</commit_message>
<xml_diff>
--- a/presentations/checkpoint-2026-10-24/exports/SafeWatch_Checkpoint_2026-10-24.pptx
+++ b/presentations/checkpoint-2026-10-24/exports/SafeWatch_Checkpoint_2026-10-24.pptx
@@ -517,7 +517,7 @@
 Роли — продуктовая модель, а не заявление о готовности всех пяти рабочих мест. В текущем frontend правила, статистика, управленческие и административные экраны представлены заглушками. На первом слайде сгенерированная промышленная иллюстрация, не фотография установки SafeWatch.
 ИСТОЧНИКИ
 main@353c7f96:tech.md §2, строки 28–42
-front/control-room@8161719d:frontend/src/App.tsx; research/frontend-evidence.md
+front/control-room@1b8822ef:frontend/src/App.tsx; research/frontend-evidence.md
 Формат: один полноразмерный PNG на слайд. Изображение слайда не редактируется по отдельным объектам; заметки остаются текстовыми.</a:t>
             </a:r>
             <a:endParaRPr lang="en-US" dirty="0"/>
@@ -611,11 +611,11 @@
 ТЕКСТ
 Наша архитектура сейчас рассчитана на видеоархив и эмуляцию потока. Запись загружается в LinQ Jupyter, TPU исполняет модели, детекции сохраняются в JSONL. На CPU работают трекинг, правила и сборка эпизодов. Затем сервер воспроизводит запись по своим часам и публикует события через WebSocket. Продолжающееся нарушение не должно порождать новые оповещения на каждом кадре. Просмотр, подтверждение, передача и устранение имеют разные значения. OpenAPI и WS-схема задают общую границу для заменяемого фронтенда, backend и отдельного stateful-мока.
 ПРИМЕЧАНИЯ
-Это схема целевого конвейера, не заявление об успешном сквозном LinQ-прогоне. В текущей семантике confirm красного создаёт confirmed и сразу sent_to_master; отдельное действие send_to_master также существует. Устранение выполняет мастер через resolve с обязательными мерами. Показанный журнал работает на моке; real backend S12 ещё не реализован. Автоэскалация не показана числом: main config/default.yaml enabled=true, timeout_s=45, tick_ms=500; в проверенном моке выключена без флага --escalation. Локальный user config не читался. Повтор replay создаёт новые события нового показа записи.
+Это схема целевого конвейера, не заявление об успешном сквозном LinQ-прогоне. В текущей семантике confirm красного создаёт confirmed и сразу sent_to_master; отдельное действие send_to_master также существует. Устранение выполняет мастер через resolve с обязательными мерами. Показанный журнал работает на моке. В свежем main журнал уже реализован; интеграция текущего frontend проверяется здесь на моке. Автоэскалация не показана числом: main config/default.yaml enabled=true, timeout_s=45, tick_ms=500; в проверенном моке выключена без флага --escalation. Локальный user config не читался. Повтор replay создаёт новые события нового показа записи.
 ИСТОЧНИКИ
 main@353c7f96:tech.md §2, §8.5–8.8, §8.15
 main@353c7f96:contract/openapi.json и contract/ws.schema.json
-demo/checkpoint@9f652236:tools/checkpoint-demo/
+demo/checkpoint@053683da:tools/checkpoint-demo/
 Формат: один полноразмерный PNG на слайд. Изображение слайда не редактируется по отдельным объектам; заметки остаются текстовыми.</a:t>
             </a:r>
             <a:endParaRPr lang="en-US" dirty="0"/>
@@ -904,14 +904,14 @@
               <a:t>СЛАЙД 5/8 · Что уже собрано
 БЮДЖЕТ ВЫСТУПЛЕНИЯ: 35 с (план, не измерение).
 ТЕКСТ
-В main закрыты слайсы S0–S10 с записанными долгами. Контракт, события и переходы реакции реализованы; стабильность LinQ отдельно не доказана. Правила бега, падения, сближения, телефона, ограждения и опасной зоны проверялись на синтетике. На экране — новый снимок ветки control-room, уже после прошлой Human Review. Работа оператора, мастера и журнал проверены на совместимом моке. Его свежий smoke дал тридцать из тридцати. Настоящий журнал backend, подключение дополнительных моделей и оставшиеся сценарии ещё требуют работы.
+Проверенная основа backend и контракта включает S0–S11 с записанными долгами. Стабильность LinQ отдельно не доказана. Правила детекции проверялись на синтетике. На экране — новый снимок текущего control-room: тёмный Premiere-скин, быстрые действия прямо в панели, сводка смены и видимое отсутствие наблюдения. Путь оператора до мастера и журнал проверены на совместимом моке. Дополнительные модели и оставшиеся сценарии требуют дальнейшей проверки.
 ПРИМЕЧАНИЯ
-Снимок 01-control-room.png: front/control-room@8161719d, runtime localhost5317, stateful-мок demo/checkpoint@9f652236 на4310/4311,24.10 08:28–08:29МСК. Камерные кадры синтетические, не заводские источники; наблюдение7/8 на UI — mock flags. Правила extra (fire/smoking/no_harness/suspended_load) присутствуют, но нужные классы моделей в main не подключены. Перенос груза load_carrying skeleton. Каска из matvey_cv ещё не интегрирована в main. Журнал/backendS12, statsS13, evalS14,deliveryS15 возвращают501/NotImplementedError. R10 закрыт; следующий шаг progress — S11. Долг extra/recompute исправлен в R10. Fresh mock smoke PASS30 FAIL0 SKIP0,26 REST responses и32 WS messages; не smoke real backend. JS pageerrors0; ожидаемый camera/view501 из-за отсутствия видео в моке.
+Снимки заново получены с front/control-room@1b8822ef и tools/checkpoint-demo@053683da. Показ: http://localhost:5173, мок REST4010 и WS4011. Последовательность reset → next → next --force. В матрице указана запрошенная проверенная основа S0–S11; свежий main продвинулся дальше. Журнал и статистика backend уже реализованы по текущему коду, но демонстрация остаётся на stateful-моке. Камерные кадры синтетические, рамки ручные. Новых численных результатов CV эта правка не добавляет.
 ИСТОЧНИКИ
-main@353c7f96:progress.md, services.py, rules/, config/models.yaml
-research/smoke-mock-fresh.json
+main@b4fb994c63f3ce187d22491080f75ffac37797c3:progress.md
+front/control-room@1b8822ef86e7d5540967e73e9e4c606e926d01c1:frontend/src/features/Operator.tsx
 research/frontend-evidence.md
-assets/screenshots/01-control-room.png
+research/revision-r3/source-index.json
 Формат: один полноразмерный PNG на слайд. Изображение слайда не редактируется по отдельным объектам; заметки остаются текстовыми.</a:t>
             </a:r>
             <a:endParaRPr lang="en-US" dirty="0"/>
@@ -1005,7 +1005,7 @@
 ТЕКСТ
 Перехожу в работающий фронтенд. Первый шаг — жёлтое событие бега: оператор открывает его и подтверждает. Второй — красная тревога падения: открываем доказательство, проверяем причину и передаём мастеру. В текущем сценарии подтверждение красного сразу инициирует передачу. Третий шаг — мастер с телефона принимает поручение, указывает меры и отправляет отчёт. Возвращаемся в журнал и видим результат и комментарий. Демонстрационные данные. Кадры синтетические. Рамки размечены вручную. Здесь мы демонстрируем пользовательский путь, а не измеряем качество нейросети.
 ПРИМЕЧАНИЯ
-Слайд — фон для живого показа, не приложение для презентации. Runtime фронта http://127.0.0.1:5317; REST4310,WS4311, их запуск в README и research/frontend-evidence.md. Перед демонстрацией сбросить ТОЛЬКО свой mock, не owner backend. Путь: режиссёр scenario yellow_running→queue→Открыть событие→Подтвердить; scenario red_fall→автоматический takeover→Открыть доказательство→Подтвердить(sent_to_master); role Мастер смены→Принять в работу→Принятые меры→Отправить отчёт и завершить; role Охрана труда→Журнал→Открыть историю. Все действия прошли в fresh capture. Видео/эфир в моке не реализованы: доступны still previews и evidence, camera/view501, «Запись не привязана» правдиво видна. Автоэскалация в этом mock run выключена. Если live demo недоступен, открыть исходные screenshots06/07/10/12/14/15; не выдавать их за текущий live run.
+Слайд — фон для живого показа, не приложение для презентации. Runtime фронта http://localhost:5173; REST4010,WS4011, их запуск в README и research/frontend-evidence.md. Перед демонстрацией сбросить ТОЛЬКО свой mock, не owner backend. Путь: режиссёр scenario yellow_running→queue→Открыть событие→Подтвердить; scenario red_fall→автоматический takeover→Открыть доказательство→Подтвердить(sent_to_master); role Мастер смены→Принять в работу→Принятые меры→Отправить отчёт и завершить; role Охрана труда→Журнал→Открыть историю. Все действия прошли в fresh capture. Видео/эфир в моке не реализованы: доступны still previews и evidence, camera/view501, «Запись не привязана» правдиво видна. Автоэскалация в этом mock run выключена. Если live demo недоступен, открыть исходные screenshots06/07/10/12/14/15; не выдавать их за текущий live run.
 ИСТОЧНИКИ
 research/frontend-evidence.md
 research/frontend-capture-raw.json
@@ -1103,13 +1103,16 @@
               <a:t>СЛАЙД 7/8 · Что остаётся до финальной защиты
 БЮДЖЕТ ВЫСТУПЛЕНИЯ: 25 с (план, не измерение).
 ТЕКСТ
-До защиты приоритетны шесть направлений. Стабилизировать интегрированный прогон LinQ. Подключить собственные модели в общий конвейер и проверить его целиком. Измерить Precision и Recall на размеченных видео с независимой проверкой. Оценить ложные тревоги на камеро-час и задержку от события до оповещения. Завершить оставшиеся сценарии и настоящий журнал backend. Конкретных значений этих метрик пока не обещаем.
+До защиты нужно стабилизировать интегрированный прогон LinQ, подключить свои модели в общий конвейер и измерить качество на размеченных видео. Отдельно оценить ложные тревоги на камеро-час и задержку до оповещения. Наше отличие — полный цикл тревоги до мастера, сводка смены, видимое отсутствие наблюдения и происхождение каждого события. Ближайший конкурент на LinQ в позиционировании команды — IVA CV.
 ПРИМЕЧАНИЯ
-Не повторять устаревшую задачу «впервые запустить собственные модели на TPU»: hardware execution уже подтверждено. Эпизодные метрики нарушений, object-box diagnostics, model fidelity и software tests — разные виды проверки. Сгенерированная камера — иллюстрация, не доказательство установки на предприятии.
+Приоритеты сохранены без новых чисел и сроков. Журнал backend уже реализован в свежем main. Формулировка «ближайший конкурент» — позиционирование команды, а не независимый рейтинг или сравнение качества. Официальная страница IVA CV https://ivacv.ru/platforma/ прямо перечисляет поддержку LinQ(TPU); https://ivacv.ru/iva-cv/ описывает видеоаналитику безопасности. Отличия SafeWatch перечисляют проверенный пользовательский путь и наблюдаемость, не утверждают отсутствие таких функций у IVA CV.
 ИСТОЧНИКИ
 main@353c7f96:progress.md, открытые долги и S11–S15
 matvey_cv@1bdeeafc:ml/EVAL_REPORT.md, independent final test NOT_RUN
 research/technical-evidence.md
+https://ivacv.ru/platforma/
+https://ivacv.ru/iva-cv/
+research/revision-r3/source-index.json
 Формат: один полноразмерный PNG на слайд. Изображение слайда не редактируется по отдельным объектам; заметки остаются текстовыми.</a:t>
             </a:r>
             <a:endParaRPr lang="en-US" dirty="0"/>

</xml_diff>